<commit_message>
báo cáo: cập nhật bản chỉnh sửa chính thức báo cáo Word, bản PDF và slide thuyết trình
</commit_message>
<xml_diff>
--- a/Nhom12_BaoCao_Slides.pptx
+++ b/Nhom12_BaoCao_Slides.pptx
@@ -1716,7 +1716,7 @@
           <a:p>
             <a:fld id="{5BCAD085-E8A6-8845-BD4E-CB4CCA059FC4}" type="datetimeFigureOut">
               <a:rPr lang="en-US" smtClean="0"/>
-              <a:t>10/23/2026</a:t>
+              <a:t>10/26/2026</a:t>
             </a:fld>
             <a:endParaRPr lang="en-US"/>
           </a:p>
@@ -1884,7 +1884,7 @@
           <a:p>
             <a:fld id="{5BCAD085-E8A6-8845-BD4E-CB4CCA059FC4}" type="datetimeFigureOut">
               <a:rPr lang="en-US" smtClean="0"/>
-              <a:t>10/23/2026</a:t>
+              <a:t>10/26/2026</a:t>
             </a:fld>
             <a:endParaRPr lang="en-US"/>
           </a:p>
@@ -2062,7 +2062,7 @@
           <a:p>
             <a:fld id="{5BCAD085-E8A6-8845-BD4E-CB4CCA059FC4}" type="datetimeFigureOut">
               <a:rPr lang="en-US" smtClean="0"/>
-              <a:t>10/23/2026</a:t>
+              <a:t>10/26/2026</a:t>
             </a:fld>
             <a:endParaRPr lang="en-US"/>
           </a:p>
@@ -2230,7 +2230,7 @@
           <a:p>
             <a:fld id="{5BCAD085-E8A6-8845-BD4E-CB4CCA059FC4}" type="datetimeFigureOut">
               <a:rPr lang="en-US" smtClean="0"/>
-              <a:t>10/23/2026</a:t>
+              <a:t>10/26/2026</a:t>
             </a:fld>
             <a:endParaRPr lang="en-US"/>
           </a:p>
@@ -2475,7 +2475,7 @@
           <a:p>
             <a:fld id="{5BCAD085-E8A6-8845-BD4E-CB4CCA059FC4}" type="datetimeFigureOut">
               <a:rPr lang="en-US" smtClean="0"/>
-              <a:t>10/23/2026</a:t>
+              <a:t>10/26/2026</a:t>
             </a:fld>
             <a:endParaRPr lang="en-US"/>
           </a:p>
@@ -2760,7 +2760,7 @@
           <a:p>
             <a:fld id="{5BCAD085-E8A6-8845-BD4E-CB4CCA059FC4}" type="datetimeFigureOut">
               <a:rPr lang="en-US" smtClean="0"/>
-              <a:t>10/23/2026</a:t>
+              <a:t>10/26/2026</a:t>
             </a:fld>
             <a:endParaRPr lang="en-US"/>
           </a:p>
@@ -3179,7 +3179,7 @@
           <a:p>
             <a:fld id="{5BCAD085-E8A6-8845-BD4E-CB4CCA059FC4}" type="datetimeFigureOut">
               <a:rPr lang="en-US" smtClean="0"/>
-              <a:t>10/23/2026</a:t>
+              <a:t>10/26/2026</a:t>
             </a:fld>
             <a:endParaRPr lang="en-US"/>
           </a:p>
@@ -3296,7 +3296,7 @@
           <a:p>
             <a:fld id="{5BCAD085-E8A6-8845-BD4E-CB4CCA059FC4}" type="datetimeFigureOut">
               <a:rPr lang="en-US" smtClean="0"/>
-              <a:t>10/23/2026</a:t>
+              <a:t>10/26/2026</a:t>
             </a:fld>
             <a:endParaRPr lang="en-US"/>
           </a:p>
@@ -3391,7 +3391,7 @@
           <a:p>
             <a:fld id="{5BCAD085-E8A6-8845-BD4E-CB4CCA059FC4}" type="datetimeFigureOut">
               <a:rPr lang="en-US" smtClean="0"/>
-              <a:t>10/23/2026</a:t>
+              <a:t>10/26/2026</a:t>
             </a:fld>
             <a:endParaRPr lang="en-US"/>
           </a:p>
@@ -3666,7 +3666,7 @@
           <a:p>
             <a:fld id="{5BCAD085-E8A6-8845-BD4E-CB4CCA059FC4}" type="datetimeFigureOut">
               <a:rPr lang="en-US" smtClean="0"/>
-              <a:t>10/23/2026</a:t>
+              <a:t>10/26/2026</a:t>
             </a:fld>
             <a:endParaRPr lang="en-US"/>
           </a:p>
@@ -3918,7 +3918,7 @@
           <a:p>
             <a:fld id="{5BCAD085-E8A6-8845-BD4E-CB4CCA059FC4}" type="datetimeFigureOut">
               <a:rPr lang="en-US" smtClean="0"/>
-              <a:t>10/23/2026</a:t>
+              <a:t>10/26/2026</a:t>
             </a:fld>
             <a:endParaRPr lang="en-US"/>
           </a:p>
@@ -4129,7 +4129,7 @@
           <a:p>
             <a:fld id="{5BCAD085-E8A6-8845-BD4E-CB4CCA059FC4}" type="datetimeFigureOut">
               <a:rPr lang="en-US" smtClean="0"/>
-              <a:t>10/23/2026</a:t>
+              <a:t>10/26/2026</a:t>
             </a:fld>
             <a:endParaRPr lang="en-US"/>
           </a:p>
@@ -4670,8 +4670,8 @@
         </p:nvSpPr>
         <p:spPr>
           <a:xfrm>
-            <a:off x="1097280" y="3392864"/>
-            <a:ext cx="2926080" cy="1169551"/>
+            <a:off x="1097280" y="3277448"/>
+            <a:ext cx="2926080" cy="1400383"/>
           </a:xfrm>
           <a:prstGeom prst="rect">
             <a:avLst/>
@@ -4725,8 +4725,20 @@
               </a:defRPr>
             </a:pPr>
             <a:r>
-              <a:t>Phần 1: Dữ liệu &amp; Tiền xử lý</a:t>
-            </a:r>
+              <a:t>Phần 1: Dữ liệu</a:t>
+            </a:r>
+            <a:r>
+              <a:rPr lang="en-US"/>
+              <a:t>,</a:t>
+            </a:r>
+            <a:r>
+              <a:t>Tiền xử lý</a:t>
+            </a:r>
+            <a:r>
+              <a:rPr lang="en-US"/>
+              <a:t> &amp; Demo</a:t>
+            </a:r>
+            <a:endParaRPr/>
           </a:p>
         </p:txBody>
       </p:sp>
@@ -4953,7 +4965,7 @@
               </a:defRPr>
             </a:pPr>
             <a:r>
-              <a:t>Phần 3: Diễn giải tri thức &amp; Demo</a:t>
+              <a:t>Phần 3: Diễn giải tri thức</a:t>
             </a:r>
           </a:p>
         </p:txBody>
@@ -7586,8 +7598,8 @@
         </p:blipFill>
         <p:spPr>
           <a:xfrm>
-            <a:off x="5897879" y="2332638"/>
-            <a:ext cx="5425135" cy="3107122"/>
+            <a:off x="5897879" y="1683939"/>
+            <a:ext cx="5425135" cy="4395375"/>
           </a:xfrm>
           <a:prstGeom prst="rect">
             <a:avLst/>
@@ -10794,8 +10806,8 @@
         </p:nvSpPr>
         <p:spPr>
           <a:xfrm>
-            <a:off x="1097280" y="3931920"/>
-            <a:ext cx="2926080" cy="2057400"/>
+            <a:off x="1097280" y="4292488"/>
+            <a:ext cx="2926080" cy="1336263"/>
           </a:xfrm>
           <a:prstGeom prst="rect">
             <a:avLst/>
@@ -10849,8 +10861,20 @@
               </a:defRPr>
             </a:pPr>
             <a:r>
-              <a:t>Phần 1: Dữ liệu &amp; Tiền xử lý</a:t>
-            </a:r>
+              <a:t>Phần 1: Dữ liệu</a:t>
+            </a:r>
+            <a:r>
+              <a:rPr lang="en-US"/>
+              <a:t>,  </a:t>
+            </a:r>
+            <a:r>
+              <a:t>Tiền xử lý</a:t>
+            </a:r>
+            <a:r>
+              <a:rPr lang="en-US"/>
+              <a:t> &amp; Demo</a:t>
+            </a:r>
+            <a:endParaRPr/>
           </a:p>
         </p:txBody>
       </p:sp>
@@ -11022,8 +11046,8 @@
         </p:nvSpPr>
         <p:spPr>
           <a:xfrm>
-            <a:off x="8156448" y="3931920"/>
-            <a:ext cx="2926080" cy="2057400"/>
+            <a:off x="8156448" y="4519473"/>
+            <a:ext cx="2926080" cy="882293"/>
           </a:xfrm>
           <a:prstGeom prst="rect">
             <a:avLst/>
@@ -11077,7 +11101,7 @@
               </a:defRPr>
             </a:pPr>
             <a:r>
-              <a:t>Phần 3: Diễn giải tri thức &amp; Demo</a:t>
+              <a:t>Phần 3: Diễn giải tri thức &amp;</a:t>
             </a:r>
           </a:p>
         </p:txBody>
@@ -13403,7 +13427,14 @@
               <a:t>-</a:t>
             </a:r>
             <a:r>
-              <a:t> Độ lệch dữ liệu mạnh: Chỉ số Tham nhũng (skewness = 1.52) và Hảo tâm (1.04) lệch phải rất mạnh.</a:t>
+              <a:t> Độ lệch dữ liệu mạnh: Chỉ số Tham nhũng (skewness = 1.52) và </a:t>
+            </a:r>
+            <a:r>
+              <a:rPr lang="en-US"/>
+              <a:t>long h</a:t>
+            </a:r>
+            <a:r>
+              <a:t>ảo tâm (1.04) lệch phải rất mạnh.</a:t>
             </a:r>
           </a:p>
           <a:p>
@@ -13717,8 +13748,8 @@
           </a:p>
         </p:txBody>
       </p:sp>
-      <mc:AlternateContent xmlns:mc="http://schemas.openxmlformats.org/markup-compatibility/2006">
-        <mc:Choice xmlns:a14="http://schemas.microsoft.com/office/drawing/2010/main" Requires="a14">
+      <mc:AlternateContent xmlns:mc="http://schemas.openxmlformats.org/markup-compatibility/2006" xmlns:a14="http://schemas.microsoft.com/office/drawing/2010/main">
+        <mc:Choice Requires="a14">
           <p:sp>
             <p:nvSpPr>
               <p:cNvPr id="5" name="TextBox 4"/>
@@ -13897,7 +13928,7 @@
             </p:txBody>
           </p:sp>
         </mc:Choice>
-        <mc:Fallback>
+        <mc:Fallback xmlns="">
           <p:sp>
             <p:nvSpPr>
               <p:cNvPr id="5" name="TextBox 4"/>
@@ -13999,7 +14030,7 @@
         <p:spPr>
           <a:xfrm>
             <a:off x="5131693" y="1700784"/>
-            <a:ext cx="6079409" cy="4232295"/>
+            <a:ext cx="6079409" cy="4075677"/>
           </a:xfrm>
           <a:prstGeom prst="rect">
             <a:avLst/>

</xml_diff>